<commit_message>
Sequence Borrow Smart Side 03 reveal
</commit_message>
<xml_diff>
--- a/decks/borrow-smart-university.pptx
+++ b/decks/borrow-smart-university.pptx
@@ -2,35 +2,35 @@
 <file path=ppt/presentation.xml><?xml version="1.0" encoding="utf-8"?>
 <p:presentation xmlns:p="http://schemas.openxmlformats.org/presentationml/2006/main">
   <p:sldMasterIdLst>
-    <p:sldMasterId xmlns:r="http://schemas.openxmlformats.org/officeDocument/2006/relationships" id="2147483648" r:id="R70c69a56712743b2"/>
+    <p:sldMasterId xmlns:r="http://schemas.openxmlformats.org/officeDocument/2006/relationships" id="2147483648" r:id="R0b7a3e081eaf4a81"/>
   </p:sldMasterIdLst>
   <p:notesMasterIdLst>
-    <p:notesMasterId xmlns:r="http://schemas.openxmlformats.org/officeDocument/2006/relationships" r:id="Rc7e091381f0c4f32"/>
+    <p:notesMasterId xmlns:r="http://schemas.openxmlformats.org/officeDocument/2006/relationships" r:id="R06419470061d421d"/>
   </p:notesMasterIdLst>
   <p:sldIdLst>
-    <p:sldId xmlns:r="http://schemas.openxmlformats.org/officeDocument/2006/relationships" id="256" r:id="R05faa80c5c5a42e8"/>
-    <p:sldId xmlns:r="http://schemas.openxmlformats.org/officeDocument/2006/relationships" id="257" r:id="Rc66c0f31676246fa"/>
-    <p:sldId xmlns:r="http://schemas.openxmlformats.org/officeDocument/2006/relationships" id="258" r:id="Rc8a172d801474425"/>
-    <p:sldId xmlns:r="http://schemas.openxmlformats.org/officeDocument/2006/relationships" id="259" r:id="Ra6d9cc58ebaa467c"/>
-    <p:sldId xmlns:r="http://schemas.openxmlformats.org/officeDocument/2006/relationships" id="260" r:id="R2c4c197f168e4ec5"/>
-    <p:sldId xmlns:r="http://schemas.openxmlformats.org/officeDocument/2006/relationships" id="261" r:id="R8e11c66d9d29449c"/>
-    <p:sldId xmlns:r="http://schemas.openxmlformats.org/officeDocument/2006/relationships" id="262" r:id="Rf6c4ef5461634786"/>
-    <p:sldId xmlns:r="http://schemas.openxmlformats.org/officeDocument/2006/relationships" id="263" r:id="R9d019a7a030a465c"/>
-    <p:sldId xmlns:r="http://schemas.openxmlformats.org/officeDocument/2006/relationships" id="264" r:id="Ra2fd762873ea4beb"/>
-    <p:sldId xmlns:r="http://schemas.openxmlformats.org/officeDocument/2006/relationships" id="265" r:id="R6c0ea2e75b1a4087"/>
-    <p:sldId xmlns:r="http://schemas.openxmlformats.org/officeDocument/2006/relationships" id="266" r:id="Racc9461ecf744f45"/>
-    <p:sldId xmlns:r="http://schemas.openxmlformats.org/officeDocument/2006/relationships" id="267" r:id="R19ebbf3d3cc64e9a"/>
-    <p:sldId xmlns:r="http://schemas.openxmlformats.org/officeDocument/2006/relationships" id="268" r:id="R3c1e00a7938c438b"/>
-    <p:sldId xmlns:r="http://schemas.openxmlformats.org/officeDocument/2006/relationships" id="269" r:id="Ra817b67244fe4ef4"/>
-    <p:sldId xmlns:r="http://schemas.openxmlformats.org/officeDocument/2006/relationships" id="270" r:id="Rd32b63c2801f4655"/>
-    <p:sldId xmlns:r="http://schemas.openxmlformats.org/officeDocument/2006/relationships" id="271" r:id="Rb21bc72b6d9b43b3"/>
-    <p:sldId xmlns:r="http://schemas.openxmlformats.org/officeDocument/2006/relationships" id="272" r:id="R8181fc7e42844b22"/>
-    <p:sldId xmlns:r="http://schemas.openxmlformats.org/officeDocument/2006/relationships" id="273" r:id="R052a90e147c24d11"/>
-    <p:sldId xmlns:r="http://schemas.openxmlformats.org/officeDocument/2006/relationships" id="274" r:id="Rb0f5e430e4d4409a"/>
-    <p:sldId xmlns:r="http://schemas.openxmlformats.org/officeDocument/2006/relationships" id="275" r:id="R0aa04d2be87f43c0"/>
-    <p:sldId xmlns:r="http://schemas.openxmlformats.org/officeDocument/2006/relationships" id="276" r:id="Re22115fc00a3484f"/>
-    <p:sldId xmlns:r="http://schemas.openxmlformats.org/officeDocument/2006/relationships" id="277" r:id="R4648228c4d094d8d"/>
-    <p:sldId xmlns:r="http://schemas.openxmlformats.org/officeDocument/2006/relationships" id="278" r:id="R71bdf7d19f78441e"/>
+    <p:sldId xmlns:r="http://schemas.openxmlformats.org/officeDocument/2006/relationships" id="256" r:id="R6c6477fa5d31424e"/>
+    <p:sldId xmlns:r="http://schemas.openxmlformats.org/officeDocument/2006/relationships" id="257" r:id="Rb7b66ff2c28e4550"/>
+    <p:sldId xmlns:r="http://schemas.openxmlformats.org/officeDocument/2006/relationships" id="258" r:id="R20d728a85cbd4118"/>
+    <p:sldId xmlns:r="http://schemas.openxmlformats.org/officeDocument/2006/relationships" id="259" r:id="R97d99cf50cda4bb6"/>
+    <p:sldId xmlns:r="http://schemas.openxmlformats.org/officeDocument/2006/relationships" id="260" r:id="R37fc2c413a754f01"/>
+    <p:sldId xmlns:r="http://schemas.openxmlformats.org/officeDocument/2006/relationships" id="261" r:id="R39d23dee8b794d95"/>
+    <p:sldId xmlns:r="http://schemas.openxmlformats.org/officeDocument/2006/relationships" id="262" r:id="R96ecfffb974349b5"/>
+    <p:sldId xmlns:r="http://schemas.openxmlformats.org/officeDocument/2006/relationships" id="263" r:id="R0c46f3eaca6a4755"/>
+    <p:sldId xmlns:r="http://schemas.openxmlformats.org/officeDocument/2006/relationships" id="264" r:id="R016d767e5a014c5f"/>
+    <p:sldId xmlns:r="http://schemas.openxmlformats.org/officeDocument/2006/relationships" id="265" r:id="Ra7a57e152b04426d"/>
+    <p:sldId xmlns:r="http://schemas.openxmlformats.org/officeDocument/2006/relationships" id="266" r:id="Re74c57b2c82f4ecc"/>
+    <p:sldId xmlns:r="http://schemas.openxmlformats.org/officeDocument/2006/relationships" id="267" r:id="Rdc745249b95342c0"/>
+    <p:sldId xmlns:r="http://schemas.openxmlformats.org/officeDocument/2006/relationships" id="268" r:id="R39858378fbe34bf9"/>
+    <p:sldId xmlns:r="http://schemas.openxmlformats.org/officeDocument/2006/relationships" id="269" r:id="Re3c713536a454874"/>
+    <p:sldId xmlns:r="http://schemas.openxmlformats.org/officeDocument/2006/relationships" id="270" r:id="Radee030f16fe45cb"/>
+    <p:sldId xmlns:r="http://schemas.openxmlformats.org/officeDocument/2006/relationships" id="271" r:id="R93622c07cfd74bb6"/>
+    <p:sldId xmlns:r="http://schemas.openxmlformats.org/officeDocument/2006/relationships" id="272" r:id="R39e8455a2184405a"/>
+    <p:sldId xmlns:r="http://schemas.openxmlformats.org/officeDocument/2006/relationships" id="273" r:id="R18a4bdee81e6481c"/>
+    <p:sldId xmlns:r="http://schemas.openxmlformats.org/officeDocument/2006/relationships" id="274" r:id="Rc00405c62ec14cbf"/>
+    <p:sldId xmlns:r="http://schemas.openxmlformats.org/officeDocument/2006/relationships" id="275" r:id="R3aa6f3cf483c4648"/>
+    <p:sldId xmlns:r="http://schemas.openxmlformats.org/officeDocument/2006/relationships" id="276" r:id="Rfc683cb54a994452"/>
+    <p:sldId xmlns:r="http://schemas.openxmlformats.org/officeDocument/2006/relationships" id="277" r:id="R65932a0742254dc4"/>
+    <p:sldId xmlns:r="http://schemas.openxmlformats.org/officeDocument/2006/relationships" id="278" r:id="R37469a78a12a4c76"/>
   </p:sldIdLst>
   <p:sldSz cx="12192000" cy="6858000"/>
   <p:notesSz cx="6858000" cy="9144000"/>
@@ -1964,17 +1964,27 @@
           <a:lstStyle xmlns:a="http://schemas.openxmlformats.org/drawingml/2006/main"/>
           <a:p xmlns:a="http://schemas.openxmlformats.org/drawingml/2006/main">
             <a:r>
-              <a:t>[STTS Steps 3 and 4: Roadmap plus unique mechanism. Reveal real estate, assets, liabilities, then the client at the center.]</a:t>
-            </a:r>
-          </a:p>
-          <a:p xmlns:a="http://schemas.openxmlformats.org/drawingml/2006/main">
-            <a:r>
-              <a:t>"Borrow Smart asks us to see assets, liabilities, and real estate as one connected system."</a:t>
-            </a:r>
-          </a:p>
-          <a:p xmlns:a="http://schemas.openxmlformats.org/drawingml/2006/main">
-            <a:r>
-              <a:t>"The third side is where you work every day. The client and the life they are building stay at the center of all three."</a:t>
+              <a:t>[STTS Steps 3 and 4: Roadmap plus unique mechanism. Reveal Assets, then Liabilities. Pause and ask what belongs above them. Reveal Side 03 and the triangle together. Reveal the client at the center last.]</a:t>
+            </a:r>
+          </a:p>
+          <a:p xmlns:a="http://schemas.openxmlformats.org/drawingml/2006/main">
+            <a:r>
+              <a:t>"The classic balance sheet gives us assets on one side and liabilities on the other."</a:t>
+            </a:r>
+          </a:p>
+          <a:p xmlns:a="http://schemas.openxmlformats.org/drawingml/2006/main">
+            <a:r>
+              <a:t>[Pause before the third click.]</a:t>
+            </a:r>
+          </a:p>
+          <a:p xmlns:a="http://schemas.openxmlformats.org/drawingml/2006/main">
+            <a:r>
+              <a:t>"Borrow Smart adds the third side: real estate. This is where you work every day."</a:t>
+            </a:r>
+          </a:p>
+          <a:p xmlns:a="http://schemas.openxmlformats.org/drawingml/2006/main">
+            <a:r>
+              <a:t>"The client and the life they are building stay at the center of all three."</a:t>
             </a:r>
           </a:p>
           <a:p xmlns:a="http://schemas.openxmlformats.org/drawingml/2006/main">
@@ -2377,7 +2387,7 @@
   </p:cSld>
   <p:clrMap bg1="lt1" tx1="dk1" bg2="lt2" tx2="dk2" accent1="accent1" accent2="accent2" accent3="accent3" accent4="accent4" accent5="accent5" accent6="accent6" hlink="hlink" folHlink="folHlink"/>
   <p:sldLayoutIdLst>
-    <p:sldLayoutId xmlns:r="http://schemas.openxmlformats.org/officeDocument/2006/relationships" id="2147483649" r:id="Raaeb9a9226404f38"/>
+    <p:sldLayoutId xmlns:r="http://schemas.openxmlformats.org/officeDocument/2006/relationships" id="2147483649" r:id="Rfae9a3c621cf4d3a"/>
   </p:sldLayoutIdLst>
   <p:txStyles>
     <p:titleStyle>
@@ -2932,7 +2942,7 @@
           <p:nvPr/>
         </p:nvPicPr>
         <p:blipFill>
-          <a:blip xmlns:r="http://schemas.openxmlformats.org/officeDocument/2006/relationships" xmlns:a="http://schemas.openxmlformats.org/drawingml/2006/main" r:embed="R118c85c97f6943e7"/>
+          <a:blip xmlns:r="http://schemas.openxmlformats.org/officeDocument/2006/relationships" xmlns:a="http://schemas.openxmlformats.org/drawingml/2006/main" r:embed="R7c06dee7c3594cd6"/>
           <a:srcRect xmlns:a="http://schemas.openxmlformats.org/drawingml/2006/main" l="0" t="0" r="0" b="0"/>
           <a:stretch xmlns:a="http://schemas.openxmlformats.org/drawingml/2006/main">
             <a:fillRect l="0" t="0" r="0" b="0"/>
@@ -2951,7 +2961,7 @@
     </p:spTree>
     <p:extLst>
       <p:ext uri="{BB962C8B-B14F-4D97-AF65-F5344CB8AC3E}">
-        <p14:creationId xmlns:p14="http://schemas.microsoft.com/office/powerpoint/2010/main" val="2012274376"/>
+        <p14:creationId xmlns:p14="http://schemas.microsoft.com/office/powerpoint/2010/main" val="1107034321"/>
       </p:ext>
     </p:extLst>
   </p:cSld>
@@ -2986,7 +2996,7 @@
           <p:nvPr/>
         </p:nvPicPr>
         <p:blipFill>
-          <a:blip xmlns:r="http://schemas.openxmlformats.org/officeDocument/2006/relationships" xmlns:a="http://schemas.openxmlformats.org/drawingml/2006/main" r:embed="Rd7e2b4c48d8941eb"/>
+          <a:blip xmlns:r="http://schemas.openxmlformats.org/officeDocument/2006/relationships" xmlns:a="http://schemas.openxmlformats.org/drawingml/2006/main" r:embed="R8262565cdeea4478"/>
           <a:srcRect xmlns:a="http://schemas.openxmlformats.org/drawingml/2006/main" l="0" t="0" r="0" b="0"/>
           <a:stretch xmlns:a="http://schemas.openxmlformats.org/drawingml/2006/main">
             <a:fillRect l="0" t="0" r="0" b="0"/>
@@ -3005,7 +3015,7 @@
     </p:spTree>
     <p:extLst>
       <p:ext uri="{BB962C8B-B14F-4D97-AF65-F5344CB8AC3E}">
-        <p14:creationId xmlns:p14="http://schemas.microsoft.com/office/powerpoint/2010/main" val="1778426439"/>
+        <p14:creationId xmlns:p14="http://schemas.microsoft.com/office/powerpoint/2010/main" val="1313846534"/>
       </p:ext>
     </p:extLst>
   </p:cSld>
@@ -3040,7 +3050,7 @@
           <p:nvPr/>
         </p:nvPicPr>
         <p:blipFill>
-          <a:blip xmlns:r="http://schemas.openxmlformats.org/officeDocument/2006/relationships" xmlns:a="http://schemas.openxmlformats.org/drawingml/2006/main" r:embed="R11bba329d83d4f97"/>
+          <a:blip xmlns:r="http://schemas.openxmlformats.org/officeDocument/2006/relationships" xmlns:a="http://schemas.openxmlformats.org/drawingml/2006/main" r:embed="R706f1337ef114da7"/>
           <a:srcRect xmlns:a="http://schemas.openxmlformats.org/drawingml/2006/main" l="0" t="0" r="0" b="0"/>
           <a:stretch xmlns:a="http://schemas.openxmlformats.org/drawingml/2006/main">
             <a:fillRect l="0" t="0" r="0" b="0"/>
@@ -3059,7 +3069,7 @@
     </p:spTree>
     <p:extLst>
       <p:ext uri="{BB962C8B-B14F-4D97-AF65-F5344CB8AC3E}">
-        <p14:creationId xmlns:p14="http://schemas.microsoft.com/office/powerpoint/2010/main" val="130526905"/>
+        <p14:creationId xmlns:p14="http://schemas.microsoft.com/office/powerpoint/2010/main" val="1248075582"/>
       </p:ext>
     </p:extLst>
   </p:cSld>
@@ -3094,7 +3104,7 @@
           <p:nvPr/>
         </p:nvPicPr>
         <p:blipFill>
-          <a:blip xmlns:r="http://schemas.openxmlformats.org/officeDocument/2006/relationships" xmlns:a="http://schemas.openxmlformats.org/drawingml/2006/main" r:embed="R6bed638526944674"/>
+          <a:blip xmlns:r="http://schemas.openxmlformats.org/officeDocument/2006/relationships" xmlns:a="http://schemas.openxmlformats.org/drawingml/2006/main" r:embed="Rf3e9e39fc16c47af"/>
           <a:srcRect xmlns:a="http://schemas.openxmlformats.org/drawingml/2006/main" l="0" t="0" r="0" b="0"/>
           <a:stretch xmlns:a="http://schemas.openxmlformats.org/drawingml/2006/main">
             <a:fillRect l="0" t="0" r="0" b="0"/>
@@ -3113,7 +3123,7 @@
     </p:spTree>
     <p:extLst>
       <p:ext uri="{BB962C8B-B14F-4D97-AF65-F5344CB8AC3E}">
-        <p14:creationId xmlns:p14="http://schemas.microsoft.com/office/powerpoint/2010/main" val="751362177"/>
+        <p14:creationId xmlns:p14="http://schemas.microsoft.com/office/powerpoint/2010/main" val="1165813122"/>
       </p:ext>
     </p:extLst>
   </p:cSld>
@@ -3148,7 +3158,7 @@
           <p:nvPr/>
         </p:nvPicPr>
         <p:blipFill>
-          <a:blip xmlns:r="http://schemas.openxmlformats.org/officeDocument/2006/relationships" xmlns:a="http://schemas.openxmlformats.org/drawingml/2006/main" r:embed="Rb01d69e49d2d4f81"/>
+          <a:blip xmlns:r="http://schemas.openxmlformats.org/officeDocument/2006/relationships" xmlns:a="http://schemas.openxmlformats.org/drawingml/2006/main" r:embed="R21d3340832a44842"/>
           <a:srcRect xmlns:a="http://schemas.openxmlformats.org/drawingml/2006/main" l="0" t="0" r="0" b="0"/>
           <a:stretch xmlns:a="http://schemas.openxmlformats.org/drawingml/2006/main">
             <a:fillRect l="0" t="0" r="0" b="0"/>
@@ -3167,7 +3177,7 @@
     </p:spTree>
     <p:extLst>
       <p:ext uri="{BB962C8B-B14F-4D97-AF65-F5344CB8AC3E}">
-        <p14:creationId xmlns:p14="http://schemas.microsoft.com/office/powerpoint/2010/main" val="975293729"/>
+        <p14:creationId xmlns:p14="http://schemas.microsoft.com/office/powerpoint/2010/main" val="109018898"/>
       </p:ext>
     </p:extLst>
   </p:cSld>
@@ -3202,7 +3212,7 @@
           <p:nvPr/>
         </p:nvPicPr>
         <p:blipFill>
-          <a:blip xmlns:r="http://schemas.openxmlformats.org/officeDocument/2006/relationships" xmlns:a="http://schemas.openxmlformats.org/drawingml/2006/main" r:embed="Rbf931e0359a74d4f"/>
+          <a:blip xmlns:r="http://schemas.openxmlformats.org/officeDocument/2006/relationships" xmlns:a="http://schemas.openxmlformats.org/drawingml/2006/main" r:embed="R136ed2bc0bd84ceb"/>
           <a:srcRect xmlns:a="http://schemas.openxmlformats.org/drawingml/2006/main" l="0" t="0" r="0" b="0"/>
           <a:stretch xmlns:a="http://schemas.openxmlformats.org/drawingml/2006/main">
             <a:fillRect l="0" t="0" r="0" b="0"/>
@@ -3221,7 +3231,7 @@
     </p:spTree>
     <p:extLst>
       <p:ext uri="{BB962C8B-B14F-4D97-AF65-F5344CB8AC3E}">
-        <p14:creationId xmlns:p14="http://schemas.microsoft.com/office/powerpoint/2010/main" val="1625269739"/>
+        <p14:creationId xmlns:p14="http://schemas.microsoft.com/office/powerpoint/2010/main" val="2042322804"/>
       </p:ext>
     </p:extLst>
   </p:cSld>
@@ -3256,7 +3266,7 @@
           <p:nvPr/>
         </p:nvPicPr>
         <p:blipFill>
-          <a:blip xmlns:r="http://schemas.openxmlformats.org/officeDocument/2006/relationships" xmlns:a="http://schemas.openxmlformats.org/drawingml/2006/main" r:embed="Red796220da354311"/>
+          <a:blip xmlns:r="http://schemas.openxmlformats.org/officeDocument/2006/relationships" xmlns:a="http://schemas.openxmlformats.org/drawingml/2006/main" r:embed="Rff6db10bbf864564"/>
           <a:srcRect xmlns:a="http://schemas.openxmlformats.org/drawingml/2006/main" l="0" t="0" r="0" b="0"/>
           <a:stretch xmlns:a="http://schemas.openxmlformats.org/drawingml/2006/main">
             <a:fillRect l="0" t="0" r="0" b="0"/>
@@ -3275,7 +3285,7 @@
     </p:spTree>
     <p:extLst>
       <p:ext uri="{BB962C8B-B14F-4D97-AF65-F5344CB8AC3E}">
-        <p14:creationId xmlns:p14="http://schemas.microsoft.com/office/powerpoint/2010/main" val="631156478"/>
+        <p14:creationId xmlns:p14="http://schemas.microsoft.com/office/powerpoint/2010/main" val="354743509"/>
       </p:ext>
     </p:extLst>
   </p:cSld>
@@ -3310,7 +3320,7 @@
           <p:nvPr/>
         </p:nvPicPr>
         <p:blipFill>
-          <a:blip xmlns:r="http://schemas.openxmlformats.org/officeDocument/2006/relationships" xmlns:a="http://schemas.openxmlformats.org/drawingml/2006/main" r:embed="R9c0f7736d3414454"/>
+          <a:blip xmlns:r="http://schemas.openxmlformats.org/officeDocument/2006/relationships" xmlns:a="http://schemas.openxmlformats.org/drawingml/2006/main" r:embed="R7acb708121f24412"/>
           <a:srcRect xmlns:a="http://schemas.openxmlformats.org/drawingml/2006/main" l="0" t="0" r="0" b="0"/>
           <a:stretch xmlns:a="http://schemas.openxmlformats.org/drawingml/2006/main">
             <a:fillRect l="0" t="0" r="0" b="0"/>
@@ -3329,7 +3339,7 @@
     </p:spTree>
     <p:extLst>
       <p:ext uri="{BB962C8B-B14F-4D97-AF65-F5344CB8AC3E}">
-        <p14:creationId xmlns:p14="http://schemas.microsoft.com/office/powerpoint/2010/main" val="473630915"/>
+        <p14:creationId xmlns:p14="http://schemas.microsoft.com/office/powerpoint/2010/main" val="1916618078"/>
       </p:ext>
     </p:extLst>
   </p:cSld>
@@ -3364,7 +3374,7 @@
           <p:nvPr/>
         </p:nvPicPr>
         <p:blipFill>
-          <a:blip xmlns:r="http://schemas.openxmlformats.org/officeDocument/2006/relationships" xmlns:a="http://schemas.openxmlformats.org/drawingml/2006/main" r:embed="R91576cc06e944498"/>
+          <a:blip xmlns:r="http://schemas.openxmlformats.org/officeDocument/2006/relationships" xmlns:a="http://schemas.openxmlformats.org/drawingml/2006/main" r:embed="Ra33d111ed7da468a"/>
           <a:srcRect xmlns:a="http://schemas.openxmlformats.org/drawingml/2006/main" l="0" t="0" r="0" b="0"/>
           <a:stretch xmlns:a="http://schemas.openxmlformats.org/drawingml/2006/main">
             <a:fillRect l="0" t="0" r="0" b="0"/>
@@ -3383,7 +3393,7 @@
     </p:spTree>
     <p:extLst>
       <p:ext uri="{BB962C8B-B14F-4D97-AF65-F5344CB8AC3E}">
-        <p14:creationId xmlns:p14="http://schemas.microsoft.com/office/powerpoint/2010/main" val="1472590764"/>
+        <p14:creationId xmlns:p14="http://schemas.microsoft.com/office/powerpoint/2010/main" val="2004958306"/>
       </p:ext>
     </p:extLst>
   </p:cSld>
@@ -3418,7 +3428,7 @@
           <p:nvPr/>
         </p:nvPicPr>
         <p:blipFill>
-          <a:blip xmlns:r="http://schemas.openxmlformats.org/officeDocument/2006/relationships" xmlns:a="http://schemas.openxmlformats.org/drawingml/2006/main" r:embed="R2b2866328b0548e8"/>
+          <a:blip xmlns:r="http://schemas.openxmlformats.org/officeDocument/2006/relationships" xmlns:a="http://schemas.openxmlformats.org/drawingml/2006/main" r:embed="R4d1d02d718db4efd"/>
           <a:srcRect xmlns:a="http://schemas.openxmlformats.org/drawingml/2006/main" l="0" t="0" r="0" b="0"/>
           <a:stretch xmlns:a="http://schemas.openxmlformats.org/drawingml/2006/main">
             <a:fillRect l="0" t="0" r="0" b="0"/>
@@ -3437,7 +3447,7 @@
     </p:spTree>
     <p:extLst>
       <p:ext uri="{BB962C8B-B14F-4D97-AF65-F5344CB8AC3E}">
-        <p14:creationId xmlns:p14="http://schemas.microsoft.com/office/powerpoint/2010/main" val="1986194298"/>
+        <p14:creationId xmlns:p14="http://schemas.microsoft.com/office/powerpoint/2010/main" val="1249579422"/>
       </p:ext>
     </p:extLst>
   </p:cSld>
@@ -3472,7 +3482,7 @@
           <p:nvPr/>
         </p:nvPicPr>
         <p:blipFill>
-          <a:blip xmlns:r="http://schemas.openxmlformats.org/officeDocument/2006/relationships" xmlns:a="http://schemas.openxmlformats.org/drawingml/2006/main" r:embed="R6b22a120d21c432f"/>
+          <a:blip xmlns:r="http://schemas.openxmlformats.org/officeDocument/2006/relationships" xmlns:a="http://schemas.openxmlformats.org/drawingml/2006/main" r:embed="Rbbd0616560c04edd"/>
           <a:srcRect xmlns:a="http://schemas.openxmlformats.org/drawingml/2006/main" l="0" t="0" r="0" b="0"/>
           <a:stretch xmlns:a="http://schemas.openxmlformats.org/drawingml/2006/main">
             <a:fillRect l="0" t="0" r="0" b="0"/>
@@ -3491,7 +3501,7 @@
     </p:spTree>
     <p:extLst>
       <p:ext uri="{BB962C8B-B14F-4D97-AF65-F5344CB8AC3E}">
-        <p14:creationId xmlns:p14="http://schemas.microsoft.com/office/powerpoint/2010/main" val="68357195"/>
+        <p14:creationId xmlns:p14="http://schemas.microsoft.com/office/powerpoint/2010/main" val="335531867"/>
       </p:ext>
     </p:extLst>
   </p:cSld>
@@ -3526,7 +3536,7 @@
           <p:nvPr/>
         </p:nvPicPr>
         <p:blipFill>
-          <a:blip xmlns:r="http://schemas.openxmlformats.org/officeDocument/2006/relationships" xmlns:a="http://schemas.openxmlformats.org/drawingml/2006/main" r:embed="Refaa58f30f7e4f6e"/>
+          <a:blip xmlns:r="http://schemas.openxmlformats.org/officeDocument/2006/relationships" xmlns:a="http://schemas.openxmlformats.org/drawingml/2006/main" r:embed="R9492c4e8b4d145d8"/>
           <a:srcRect xmlns:a="http://schemas.openxmlformats.org/drawingml/2006/main" l="0" t="0" r="0" b="0"/>
           <a:stretch xmlns:a="http://schemas.openxmlformats.org/drawingml/2006/main">
             <a:fillRect l="0" t="0" r="0" b="0"/>
@@ -3545,7 +3555,7 @@
     </p:spTree>
     <p:extLst>
       <p:ext uri="{BB962C8B-B14F-4D97-AF65-F5344CB8AC3E}">
-        <p14:creationId xmlns:p14="http://schemas.microsoft.com/office/powerpoint/2010/main" val="2015717270"/>
+        <p14:creationId xmlns:p14="http://schemas.microsoft.com/office/powerpoint/2010/main" val="248509694"/>
       </p:ext>
     </p:extLst>
   </p:cSld>
@@ -3580,7 +3590,7 @@
           <p:nvPr/>
         </p:nvPicPr>
         <p:blipFill>
-          <a:blip xmlns:r="http://schemas.openxmlformats.org/officeDocument/2006/relationships" xmlns:a="http://schemas.openxmlformats.org/drawingml/2006/main" r:embed="Rb6be565bb2584bb2"/>
+          <a:blip xmlns:r="http://schemas.openxmlformats.org/officeDocument/2006/relationships" xmlns:a="http://schemas.openxmlformats.org/drawingml/2006/main" r:embed="R7d0332a0608d4cbf"/>
           <a:srcRect xmlns:a="http://schemas.openxmlformats.org/drawingml/2006/main" l="0" t="0" r="0" b="0"/>
           <a:stretch xmlns:a="http://schemas.openxmlformats.org/drawingml/2006/main">
             <a:fillRect l="0" t="0" r="0" b="0"/>
@@ -3599,7 +3609,7 @@
     </p:spTree>
     <p:extLst>
       <p:ext uri="{BB962C8B-B14F-4D97-AF65-F5344CB8AC3E}">
-        <p14:creationId xmlns:p14="http://schemas.microsoft.com/office/powerpoint/2010/main" val="1393011778"/>
+        <p14:creationId xmlns:p14="http://schemas.microsoft.com/office/powerpoint/2010/main" val="435010688"/>
       </p:ext>
     </p:extLst>
   </p:cSld>
@@ -3634,7 +3644,7 @@
           <p:nvPr/>
         </p:nvPicPr>
         <p:blipFill>
-          <a:blip xmlns:r="http://schemas.openxmlformats.org/officeDocument/2006/relationships" xmlns:a="http://schemas.openxmlformats.org/drawingml/2006/main" r:embed="Rde9e09da5a724c4a"/>
+          <a:blip xmlns:r="http://schemas.openxmlformats.org/officeDocument/2006/relationships" xmlns:a="http://schemas.openxmlformats.org/drawingml/2006/main" r:embed="R3d55608f4e8d4498"/>
           <a:srcRect xmlns:a="http://schemas.openxmlformats.org/drawingml/2006/main" l="0" t="0" r="0" b="0"/>
           <a:stretch xmlns:a="http://schemas.openxmlformats.org/drawingml/2006/main">
             <a:fillRect l="0" t="0" r="0" b="0"/>
@@ -3653,7 +3663,7 @@
     </p:spTree>
     <p:extLst>
       <p:ext uri="{BB962C8B-B14F-4D97-AF65-F5344CB8AC3E}">
-        <p14:creationId xmlns:p14="http://schemas.microsoft.com/office/powerpoint/2010/main" val="880889286"/>
+        <p14:creationId xmlns:p14="http://schemas.microsoft.com/office/powerpoint/2010/main" val="1035102062"/>
       </p:ext>
     </p:extLst>
   </p:cSld>
@@ -3688,7 +3698,7 @@
           <p:nvPr/>
         </p:nvPicPr>
         <p:blipFill>
-          <a:blip xmlns:r="http://schemas.openxmlformats.org/officeDocument/2006/relationships" xmlns:a="http://schemas.openxmlformats.org/drawingml/2006/main" r:embed="Rfe9cd0e5538e43fa"/>
+          <a:blip xmlns:r="http://schemas.openxmlformats.org/officeDocument/2006/relationships" xmlns:a="http://schemas.openxmlformats.org/drawingml/2006/main" r:embed="R2425c8d07da649c0"/>
           <a:srcRect xmlns:a="http://schemas.openxmlformats.org/drawingml/2006/main" l="0" t="0" r="0" b="0"/>
           <a:stretch xmlns:a="http://schemas.openxmlformats.org/drawingml/2006/main">
             <a:fillRect l="0" t="0" r="0" b="0"/>
@@ -3707,7 +3717,7 @@
     </p:spTree>
     <p:extLst>
       <p:ext uri="{BB962C8B-B14F-4D97-AF65-F5344CB8AC3E}">
-        <p14:creationId xmlns:p14="http://schemas.microsoft.com/office/powerpoint/2010/main" val="1649327370"/>
+        <p14:creationId xmlns:p14="http://schemas.microsoft.com/office/powerpoint/2010/main" val="1257941468"/>
       </p:ext>
     </p:extLst>
   </p:cSld>
@@ -3742,7 +3752,7 @@
           <p:nvPr/>
         </p:nvPicPr>
         <p:blipFill>
-          <a:blip xmlns:r="http://schemas.openxmlformats.org/officeDocument/2006/relationships" xmlns:a="http://schemas.openxmlformats.org/drawingml/2006/main" r:embed="Rd36df7ef7cf24117"/>
+          <a:blip xmlns:r="http://schemas.openxmlformats.org/officeDocument/2006/relationships" xmlns:a="http://schemas.openxmlformats.org/drawingml/2006/main" r:embed="Rd3d92d24d8424dcf"/>
           <a:srcRect xmlns:a="http://schemas.openxmlformats.org/drawingml/2006/main" l="0" t="0" r="0" b="0"/>
           <a:stretch xmlns:a="http://schemas.openxmlformats.org/drawingml/2006/main">
             <a:fillRect l="0" t="0" r="0" b="0"/>
@@ -3761,7 +3771,7 @@
     </p:spTree>
     <p:extLst>
       <p:ext uri="{BB962C8B-B14F-4D97-AF65-F5344CB8AC3E}">
-        <p14:creationId xmlns:p14="http://schemas.microsoft.com/office/powerpoint/2010/main" val="791284211"/>
+        <p14:creationId xmlns:p14="http://schemas.microsoft.com/office/powerpoint/2010/main" val="644280482"/>
       </p:ext>
     </p:extLst>
   </p:cSld>
@@ -3796,7 +3806,7 @@
           <p:nvPr/>
         </p:nvPicPr>
         <p:blipFill>
-          <a:blip xmlns:r="http://schemas.openxmlformats.org/officeDocument/2006/relationships" xmlns:a="http://schemas.openxmlformats.org/drawingml/2006/main" r:embed="R0543366ef0434fd4"/>
+          <a:blip xmlns:r="http://schemas.openxmlformats.org/officeDocument/2006/relationships" xmlns:a="http://schemas.openxmlformats.org/drawingml/2006/main" r:embed="R19bfc422320c440f"/>
           <a:srcRect xmlns:a="http://schemas.openxmlformats.org/drawingml/2006/main" l="0" t="0" r="0" b="0"/>
           <a:stretch xmlns:a="http://schemas.openxmlformats.org/drawingml/2006/main">
             <a:fillRect l="0" t="0" r="0" b="0"/>
@@ -3815,7 +3825,7 @@
     </p:spTree>
     <p:extLst>
       <p:ext uri="{BB962C8B-B14F-4D97-AF65-F5344CB8AC3E}">
-        <p14:creationId xmlns:p14="http://schemas.microsoft.com/office/powerpoint/2010/main" val="1926625529"/>
+        <p14:creationId xmlns:p14="http://schemas.microsoft.com/office/powerpoint/2010/main" val="1622425694"/>
       </p:ext>
     </p:extLst>
   </p:cSld>
@@ -3850,7 +3860,7 @@
           <p:nvPr/>
         </p:nvPicPr>
         <p:blipFill>
-          <a:blip xmlns:r="http://schemas.openxmlformats.org/officeDocument/2006/relationships" xmlns:a="http://schemas.openxmlformats.org/drawingml/2006/main" r:embed="Ra509badd33f74075"/>
+          <a:blip xmlns:r="http://schemas.openxmlformats.org/officeDocument/2006/relationships" xmlns:a="http://schemas.openxmlformats.org/drawingml/2006/main" r:embed="R6592283e415a4c08"/>
           <a:srcRect xmlns:a="http://schemas.openxmlformats.org/drawingml/2006/main" l="0" t="0" r="0" b="0"/>
           <a:stretch xmlns:a="http://schemas.openxmlformats.org/drawingml/2006/main">
             <a:fillRect l="0" t="0" r="0" b="0"/>
@@ -3869,7 +3879,7 @@
     </p:spTree>
     <p:extLst>
       <p:ext uri="{BB962C8B-B14F-4D97-AF65-F5344CB8AC3E}">
-        <p14:creationId xmlns:p14="http://schemas.microsoft.com/office/powerpoint/2010/main" val="460920610"/>
+        <p14:creationId xmlns:p14="http://schemas.microsoft.com/office/powerpoint/2010/main" val="276482043"/>
       </p:ext>
     </p:extLst>
   </p:cSld>
@@ -3904,7 +3914,7 @@
           <p:nvPr/>
         </p:nvPicPr>
         <p:blipFill>
-          <a:blip xmlns:r="http://schemas.openxmlformats.org/officeDocument/2006/relationships" xmlns:a="http://schemas.openxmlformats.org/drawingml/2006/main" r:embed="R315778c8f5dd4f8d"/>
+          <a:blip xmlns:r="http://schemas.openxmlformats.org/officeDocument/2006/relationships" xmlns:a="http://schemas.openxmlformats.org/drawingml/2006/main" r:embed="R61a4093fac7f47bc"/>
           <a:srcRect xmlns:a="http://schemas.openxmlformats.org/drawingml/2006/main" l="0" t="0" r="0" b="0"/>
           <a:stretch xmlns:a="http://schemas.openxmlformats.org/drawingml/2006/main">
             <a:fillRect l="0" t="0" r="0" b="0"/>
@@ -3923,7 +3933,7 @@
     </p:spTree>
     <p:extLst>
       <p:ext uri="{BB962C8B-B14F-4D97-AF65-F5344CB8AC3E}">
-        <p14:creationId xmlns:p14="http://schemas.microsoft.com/office/powerpoint/2010/main" val="374681855"/>
+        <p14:creationId xmlns:p14="http://schemas.microsoft.com/office/powerpoint/2010/main" val="777789628"/>
       </p:ext>
     </p:extLst>
   </p:cSld>
@@ -3958,7 +3968,7 @@
           <p:nvPr/>
         </p:nvPicPr>
         <p:blipFill>
-          <a:blip xmlns:r="http://schemas.openxmlformats.org/officeDocument/2006/relationships" xmlns:a="http://schemas.openxmlformats.org/drawingml/2006/main" r:embed="R12b94cc4ac6f414f"/>
+          <a:blip xmlns:r="http://schemas.openxmlformats.org/officeDocument/2006/relationships" xmlns:a="http://schemas.openxmlformats.org/drawingml/2006/main" r:embed="R2dd9b334e2a2450e"/>
           <a:srcRect xmlns:a="http://schemas.openxmlformats.org/drawingml/2006/main" l="0" t="0" r="0" b="0"/>
           <a:stretch xmlns:a="http://schemas.openxmlformats.org/drawingml/2006/main">
             <a:fillRect l="0" t="0" r="0" b="0"/>
@@ -3977,7 +3987,7 @@
     </p:spTree>
     <p:extLst>
       <p:ext uri="{BB962C8B-B14F-4D97-AF65-F5344CB8AC3E}">
-        <p14:creationId xmlns:p14="http://schemas.microsoft.com/office/powerpoint/2010/main" val="668398165"/>
+        <p14:creationId xmlns:p14="http://schemas.microsoft.com/office/powerpoint/2010/main" val="572592439"/>
       </p:ext>
     </p:extLst>
   </p:cSld>
@@ -4012,7 +4022,7 @@
           <p:nvPr/>
         </p:nvPicPr>
         <p:blipFill>
-          <a:blip xmlns:r="http://schemas.openxmlformats.org/officeDocument/2006/relationships" xmlns:a="http://schemas.openxmlformats.org/drawingml/2006/main" r:embed="Rf7d903a0873d4df8"/>
+          <a:blip xmlns:r="http://schemas.openxmlformats.org/officeDocument/2006/relationships" xmlns:a="http://schemas.openxmlformats.org/drawingml/2006/main" r:embed="R80fbdebe9ff1458c"/>
           <a:srcRect xmlns:a="http://schemas.openxmlformats.org/drawingml/2006/main" l="0" t="0" r="0" b="0"/>
           <a:stretch xmlns:a="http://schemas.openxmlformats.org/drawingml/2006/main">
             <a:fillRect l="0" t="0" r="0" b="0"/>
@@ -4031,7 +4041,7 @@
     </p:spTree>
     <p:extLst>
       <p:ext uri="{BB962C8B-B14F-4D97-AF65-F5344CB8AC3E}">
-        <p14:creationId xmlns:p14="http://schemas.microsoft.com/office/powerpoint/2010/main" val="275637315"/>
+        <p14:creationId xmlns:p14="http://schemas.microsoft.com/office/powerpoint/2010/main" val="790236998"/>
       </p:ext>
     </p:extLst>
   </p:cSld>
@@ -4066,7 +4076,7 @@
           <p:nvPr/>
         </p:nvPicPr>
         <p:blipFill>
-          <a:blip xmlns:r="http://schemas.openxmlformats.org/officeDocument/2006/relationships" xmlns:a="http://schemas.openxmlformats.org/drawingml/2006/main" r:embed="Rdb58346f26414ea8"/>
+          <a:blip xmlns:r="http://schemas.openxmlformats.org/officeDocument/2006/relationships" xmlns:a="http://schemas.openxmlformats.org/drawingml/2006/main" r:embed="R4787da19024647a4"/>
           <a:srcRect xmlns:a="http://schemas.openxmlformats.org/drawingml/2006/main" l="0" t="0" r="0" b="0"/>
           <a:stretch xmlns:a="http://schemas.openxmlformats.org/drawingml/2006/main">
             <a:fillRect l="0" t="0" r="0" b="0"/>
@@ -4085,7 +4095,7 @@
     </p:spTree>
     <p:extLst>
       <p:ext uri="{BB962C8B-B14F-4D97-AF65-F5344CB8AC3E}">
-        <p14:creationId xmlns:p14="http://schemas.microsoft.com/office/powerpoint/2010/main" val="2138926992"/>
+        <p14:creationId xmlns:p14="http://schemas.microsoft.com/office/powerpoint/2010/main" val="1449325238"/>
       </p:ext>
     </p:extLst>
   </p:cSld>
@@ -4120,7 +4130,7 @@
           <p:nvPr/>
         </p:nvPicPr>
         <p:blipFill>
-          <a:blip xmlns:r="http://schemas.openxmlformats.org/officeDocument/2006/relationships" xmlns:a="http://schemas.openxmlformats.org/drawingml/2006/main" r:embed="R8c68b7e778ef47e0"/>
+          <a:blip xmlns:r="http://schemas.openxmlformats.org/officeDocument/2006/relationships" xmlns:a="http://schemas.openxmlformats.org/drawingml/2006/main" r:embed="Rfc5e69b37894463c"/>
           <a:srcRect xmlns:a="http://schemas.openxmlformats.org/drawingml/2006/main" l="0" t="0" r="0" b="0"/>
           <a:stretch xmlns:a="http://schemas.openxmlformats.org/drawingml/2006/main">
             <a:fillRect l="0" t="0" r="0" b="0"/>
@@ -4139,7 +4149,7 @@
     </p:spTree>
     <p:extLst>
       <p:ext uri="{BB962C8B-B14F-4D97-AF65-F5344CB8AC3E}">
-        <p14:creationId xmlns:p14="http://schemas.microsoft.com/office/powerpoint/2010/main" val="824556732"/>
+        <p14:creationId xmlns:p14="http://schemas.microsoft.com/office/powerpoint/2010/main" val="461396933"/>
       </p:ext>
     </p:extLst>
   </p:cSld>

</xml_diff>